<commit_message>
fix: correct stale Civo infra refs and checkpointShareGroup tool name; add SSL incident as bug 6
</commit_message>
<xml_diff>
--- a/public/docs/Agent-Mesh-SRE-Bobathon-2026.pptx
+++ b/public/docs/Agent-Mesh-SRE-Bobathon-2026.pptx
@@ -2285,7 +2285,7 @@
                 <a:ea typeface="Arial" pitchFamily="34" charset="-122"/>
                 <a:cs typeface="Arial" pitchFamily="34" charset="-120"/>
               </a:rPr>
-              <a:t>Confluent for Kubernetes on Civo  ·  KRaft mode  ·  3 brokers  ·  7 topics  ·  Deployed on Vercel</a:t>
+              <a:t>Confluent for Kubernetes on DigitalOcean  ·  KRaft mode  ·  3 brokers  ·  7 topics  ·  Deployed on Vercel</a:t>
             </a:r>
             <a:endParaRPr lang="en-US" sz="900" dirty="0">
               <a:solidFill>
@@ -2445,7 +2445,7 @@
                 <a:ea typeface="Courier New" pitchFamily="34" charset="-122"/>
                 <a:cs typeface="Courier New" pitchFamily="34" charset="-120"/>
               </a:rPr>
-              <a:t>Confluent for Kubernetes on Civo  ·  KRaft mode  ·  RF=3  ·  212.2.248.241:9092</a:t>
+              <a:t>Confluent for Kubernetes on DigitalOcean  ·  KRaft mode  ·  RF=3  ·  64.227.25.232:31090</a:t>
             </a:r>
             <a:endParaRPr lang="en-US" sz="1050" b="1" dirty="0">
               <a:solidFill>
@@ -8995,7 +8995,7 @@
                 <a:ea typeface="Arial" pitchFamily="34" charset="-122"/>
                 <a:cs typeface="Arial" pitchFamily="34" charset="-120"/>
               </a:rPr>
-              <a:t>Each scenario produces a ranked set of candidate causes alongside the actual finding  </a:t>
+              <a:t xml:space="preserve">Each scenario produces a ranked set of candidate causes alongside the actual finding  </a:t>
             </a:r>
             <a:endParaRPr lang="en-US" sz="1300" dirty="0"/>
           </a:p>
@@ -11964,7 +11964,7 @@
                 <a:ea typeface="Arial" pitchFamily="34" charset="-122"/>
                 <a:cs typeface="Arial" pitchFamily="34" charset="-120"/>
               </a:rPr>
-              <a:t>Confluent for Kubernetes (CFK) 8.2 . Kafka . </a:t>
+              <a:t xml:space="preserve">Confluent for Kubernetes (CFK) 8.2 . Kafka . </a:t>
             </a:r>
             <a:r>
               <a:rPr lang="en-US" sz="1150" dirty="0" err="1">
@@ -11986,7 +11986,7 @@
                 <a:ea typeface="Arial" pitchFamily="34" charset="-122"/>
                 <a:cs typeface="Arial" pitchFamily="34" charset="-120"/>
               </a:rPr>
-              <a:t>  ·  </a:t>
+              <a:t xml:space="preserve">  ·  </a:t>
             </a:r>
             <a:r>
               <a:rPr lang="en-US" sz="1150" dirty="0" err="1">
@@ -11997,7 +11997,7 @@
                 <a:ea typeface="Arial" pitchFamily="34" charset="-122"/>
                 <a:cs typeface="Arial" pitchFamily="34" charset="-120"/>
               </a:rPr>
-              <a:t>Civo.com</a:t>
+              <a:t>DigitalOcean</a:t>
             </a:r>
             <a:r>
               <a:rPr lang="en-US" sz="1150" dirty="0">
@@ -12008,7 +12008,7 @@
                 <a:ea typeface="Arial" pitchFamily="34" charset="-122"/>
                 <a:cs typeface="Arial" pitchFamily="34" charset="-120"/>
               </a:rPr>
-              <a:t> Bootstrap </a:t>
+              <a:t xml:space="preserve"> Bootstrap </a:t>
             </a:r>
             <a:endParaRPr lang="en-US" sz="1150" dirty="0"/>
           </a:p>
@@ -12445,7 +12445,7 @@
                 <a:ea typeface="Arial" pitchFamily="34" charset="-122"/>
                 <a:cs typeface="Arial" pitchFamily="34" charset="-120"/>
               </a:rPr>
-              <a:t> (Free tier, Cloud Platform, self managed )  ·  Public GitHub CI  ·  Auto-deploy on push</a:t>
+              <a:t xml:space="preserve"> (Free tier, Cloud Platform, self managed )  ·  Public GitHub CI  ·  Auto-deploy on push</a:t>
             </a:r>
             <a:endParaRPr lang="en-US" sz="1150" dirty="0"/>
           </a:p>
@@ -17183,7 +17183,7 @@
                 <a:ea typeface="Arial" pitchFamily="34" charset="-122"/>
                 <a:cs typeface="Arial" pitchFamily="34" charset="-120"/>
               </a:rPr>
-              <a:t>The POC runs today at agent-mesh-sre.vercel.app  ·  Kafka cluster live on Civo  ·  Open for IBM evaluation</a:t>
+              <a:t>The POC runs today at agent-mesh-sre.vercel.app  ·  Kafka cluster live on DigitalOcean  ·  Open for IBM evaluation</a:t>
             </a:r>
             <a:endParaRPr lang="en-US" sz="1100" dirty="0"/>
           </a:p>
@@ -18725,7 +18725,7 @@
                 <a:ea typeface="Arial" pitchFamily="34" charset="-122"/>
                 <a:cs typeface="Arial" pitchFamily="34" charset="-120"/>
               </a:rPr>
-              <a:t>Live at agent-mesh-sre.vercel.app with a real Confluent for Kubernetes cluster on Civo. 11 Kafka failure scenarios, 4 human-gated approvals, full audit trail.</a:t>
+              <a:t>Live at agent-mesh-sre.vercel.app with a real Confluent for Kubernetes cluster on DigitalOcean. 11 Kafka failure scenarios, 4 human-gated approvals, full audit trail.</a:t>
             </a:r>
             <a:endParaRPr lang="en-US" sz="1100" dirty="0"/>
           </a:p>
@@ -19221,7 +19221,7 @@
                 <a:ea typeface="Courier New" pitchFamily="34" charset="-122"/>
                 <a:cs typeface="Courier New" pitchFamily="34" charset="-120"/>
               </a:rPr>
-              <a:t>agent-mesh-sre.vercel.app  ·  github.com/surajcsibm/agent-mesh-sre-real  ·  Kafka: 212.2.248.241:9092</a:t>
+              <a:t>agent-mesh-sre.vercel.app  ·  github.com/surajcsibm/agent-mesh-sre-real  ·  Kafka: 64.227.25.232:31090</a:t>
             </a:r>
             <a:endParaRPr lang="en-US" sz="1050" dirty="0"/>
           </a:p>
@@ -19295,7 +19295,7 @@
                 <a:ea typeface="Cambria" pitchFamily="34" charset="-122"/>
                 <a:cs typeface="Cambria" pitchFamily="34" charset="-120"/>
               </a:rPr>
-              <a:t>Two Roles, One Platform, </a:t>
+              <a:t xml:space="preserve">Two Roles, One Platform, </a:t>
             </a:r>
             <a:r>
               <a:rPr lang="en-US" sz="3200" b="1" dirty="0">
@@ -19315,7 +19315,7 @@
                 <a:ea typeface="Arial" pitchFamily="34" charset="-122"/>
                 <a:cs typeface="Arial" pitchFamily="34" charset="-120"/>
               </a:rPr>
-              <a:t>: </a:t>
+              <a:t xml:space="preserve">: </a:t>
             </a:r>
             <a:endParaRPr lang="en-US" sz="3200" dirty="0"/>
           </a:p>

</xml_diff>